<commit_message>
docs: verify remaining guides and refresh presentation and Office files
</commit_message>
<xml_diff>
--- a/docs/presentation/InfiMatch_Soutenance.pptx
+++ b/docs/presentation/InfiMatch_Soutenance.pptx
@@ -888,7 +888,7 @@
           <a:lstStyle/>
           <a:p>
             <a:r>
-              <a:t>La lecture CV enrichie est un lot local testé, en cours d’intégration frontend. Ne pas annoncer sa disponibilité en production avant recette.</a:t>
+              <a:t>Le CV propose des données à vérifier ; aucune qualification ni identité certifiée automatiquement. Le parcours est implémenté, la recette complète publiée reste à documenter.</a:t>
             </a:r>
           </a:p>
           <a:p>
@@ -1188,7 +1188,7 @@
           <a:lstStyle/>
           <a:p>
             <a:r>
-              <a:t>PDF refondus : preuve de déploiement connue. Suivi email enrichi et correctifs profil : locaux selon l’instantané du dossier. Source juridique S4 ; aucun conseil individuel.</a:t>
+              <a:t>Les documents et états email sont implémentés. Distinguer code livré, reçu fournisseur et réception réelle. Recetter le parcours complet sur la version remise.</a:t>
             </a:r>
           </a:p>
           <a:p>
@@ -1338,7 +1338,7 @@
           <a:lstStyle/>
           <a:p>
             <a:r>
-              <a:t>Les imports ne tournent plus dans le workflow de rappels toutes les 30 minutes. Vérifier versions actives/exécutions avant soutenance ; scénario de secours dans DEMONSTRATION.md.</a:t>
+              <a:t>Reprise et rappels publiés toutes les quatre heures ; imports séparés. Préserver le quota, réutiliser les preuves datées pertinentes. Montrer matching et confirmation comme deux workflows distincts.</a:t>
             </a:r>
           </a:p>
           <a:p>
@@ -4980,7 +4980,7 @@
               </a:defRPr>
             </a:pPr>
             <a:r>
-              <a:t>Projet étudiant · État documentaire au 19 septembre 2026 · Réserves et sources : DOSSIER_SOUTENANCE.md</a:t>
+              <a:t>Projet étudiant · État documentaire au 21 septembre 2026 · Réserves et sources : DOSSIER_SOUTENANCE.md</a:t>
             </a:r>
           </a:p>
         </p:txBody>
@@ -5634,7 +5634,7 @@
               </a:defRPr>
             </a:pPr>
             <a:r>
-              <a:t>Parcours clavier et responsive à rejouer sur la version remise. Réduire appels et doublons ; privilégier le matériel existant ou reconditionné. Pas de certification RGAA ou de bilan carbone revendiqué.</a:t>
+              <a:t>Matching local, 1 000 profils : 2 015 requêtes SQL deviennent 35, mêmes résultats comparés. Imports bornés et parsing réutilisé. Essais humains RGAA à compléter ; aucun gain CO₂ ou euros calculé.</a:t>
             </a:r>
           </a:p>
         </p:txBody>
@@ -5676,7 +5676,7 @@
               </a:defRPr>
             </a:pPr>
             <a:r>
-              <a:t>Projet étudiant · État documentaire au 19 septembre 2026 · Réserves et sources : DOSSIER_SOUTENANCE.md</a:t>
+              <a:t>Projet étudiant · État documentaire au 21 septembre 2026 · Réserves et sources : DOSSIER_SOUTENANCE.md</a:t>
             </a:r>
           </a:p>
         </p:txBody>
@@ -6330,7 +6330,7 @@
               </a:defRPr>
             </a:pPr>
             <a:r>
-              <a:t>Les heures humaines ne sont pas renseignées. Le journal contient 0,921 h d’agent historique, outils et attente inclus ; ce relevé ne représente ni l’équipe ni le travail total.</a:t>
+              <a:t>Les heures humaines doivent être renseignées dans TEMPS_HUMAINS.csv. Aucun écart estimé/réel ni coût humain fiable sans ce relevé. Le temps d’un agent ne mesure pas le travail de l’équipe.</a:t>
             </a:r>
           </a:p>
         </p:txBody>
@@ -6372,7 +6372,7 @@
               </a:defRPr>
             </a:pPr>
             <a:r>
-              <a:t>Projet étudiant · État documentaire au 19 septembre 2026 · Réserves et sources : DOSSIER_SOUTENANCE.md</a:t>
+              <a:t>Projet étudiant · État documentaire au 21 septembre 2026 · Réserves et sources : DOSSIER_SOUTENANCE.md</a:t>
             </a:r>
           </a:p>
         </p:txBody>
@@ -6856,7 +6856,7 @@
               </a:defRPr>
             </a:pPr>
             <a:r>
-              <a:t>Publier et recetter les lots locaux ; vérifier emails et nouveaux créneaux ; joindre couverture finale et SHA. Répéter le scénario et renseigner les éléments humains reportés.</a:t>
+              <a:t>Recetter le parcours publié et les deux workflows, attester le MFA réel, compléter les heures et répéter à quatre. Préserver le quota n8n. Le manifeste identifie la version remise.</a:t>
             </a:r>
           </a:p>
         </p:txBody>
@@ -7026,7 +7026,7 @@
               </a:defRPr>
             </a:pPr>
             <a:r>
-              <a:t>MFA administrateur, contrat complet et signature, fiches mission publiques / JobPosting, continuité d’hébergement n8n. Aucun de ces choix n’est activé par ce dossier.</a:t>
+              <a:t>Responsable des données et durées à formaliser ; restauration indépendante et rotation à prouver ; hébergement n8n après essai. Le MFA est implémenté, pas une proposition future.</a:t>
             </a:r>
           </a:p>
         </p:txBody>
@@ -7068,7 +7068,7 @@
               </a:defRPr>
             </a:pPr>
             <a:r>
-              <a:t>Projet étudiant · État documentaire au 19 septembre 2026 · Réserves et sources : DOSSIER_SOUTENANCE.md</a:t>
+              <a:t>Projet étudiant · État documentaire au 21 septembre 2026 · Réserves et sources : DOSSIER_SOUTENANCE.md</a:t>
             </a:r>
           </a:p>
         </p:txBody>
@@ -7764,7 +7764,7 @@
               </a:defRPr>
             </a:pPr>
             <a:r>
-              <a:t>Projet étudiant · État documentaire au 19 septembre 2026 · Réserves et sources : DOSSIER_SOUTENANCE.md</a:t>
+              <a:t>Projet étudiant · État documentaire au 21 septembre 2026 · Réserves et sources : DOSSIER_SOUTENANCE.md</a:t>
             </a:r>
           </a:p>
         </p:txBody>
@@ -8248,7 +8248,7 @@
               </a:defRPr>
             </a:pPr>
             <a:r>
-              <a:t>Profil IDE / IADE / IBODE, services d’exercice, zone de mobilité, recherche, candidatures et agenda. Le CV suggère des informations à relire ; il ne certifie aucun diplôme.</a:t>
+              <a:t>Profil IDE / IADE / IBODE, services, disponibilités et zone de recherche enregistrée, distincte du domicile. Recherche ponctuelle libre et Discord facultatif après inscription.</a:t>
             </a:r>
           </a:p>
         </p:txBody>
@@ -8460,7 +8460,7 @@
               </a:defRPr>
             </a:pPr>
             <a:r>
-              <a:t>Projet étudiant · État documentaire au 19 septembre 2026 · Réserves et sources : DOSSIER_SOUTENANCE.md</a:t>
+              <a:t>Projet étudiant · État documentaire au 21 septembre 2026 · Réserves et sources : DOSSIER_SOUTENANCE.md</a:t>
             </a:r>
           </a:p>
         </p:txBody>
@@ -9156,7 +9156,7 @@
               </a:defRPr>
             </a:pPr>
             <a:r>
-              <a:t>Projet étudiant · État documentaire au 19 septembre 2026 · Réserves et sources : DOSSIER_SOUTENANCE.md</a:t>
+              <a:t>Projet étudiant · État documentaire au 21 septembre 2026 · Réserves et sources : DOSSIER_SOUTENANCE.md</a:t>
             </a:r>
           </a:p>
         </p:txBody>
@@ -9852,7 +9852,7 @@
               </a:defRPr>
             </a:pPr>
             <a:r>
-              <a:t>Projet étudiant · État documentaire au 19 septembre 2026 · Réserves et sources : DOSSIER_SOUTENANCE.md</a:t>
+              <a:t>Projet étudiant · État documentaire au 21 septembre 2026 · Réserves et sources : DOSSIER_SOUTENANCE.md</a:t>
             </a:r>
           </a:p>
         </p:txBody>
@@ -10548,7 +10548,7 @@
               </a:defRPr>
             </a:pPr>
             <a:r>
-              <a:t>Projet étudiant · État documentaire au 19 septembre 2026 · Réserves et sources : DOSSIER_SOUTENANCE.md</a:t>
+              <a:t>Projet étudiant · État documentaire au 21 septembre 2026 · Réserves et sources : DOSSIER_SOUTENANCE.md</a:t>
             </a:r>
           </a:p>
         </p:txBody>
@@ -11244,7 +11244,7 @@
               </a:defRPr>
             </a:pPr>
             <a:r>
-              <a:t>Projet étudiant · État documentaire au 19 septembre 2026 · Réserves et sources : DOSSIER_SOUTENANCE.md</a:t>
+              <a:t>Projet étudiant · État documentaire au 21 septembre 2026 · Réserves et sources : DOSSIER_SOUTENANCE.md</a:t>
             </a:r>
           </a:p>
         </p:txBody>
@@ -11898,7 +11898,7 @@
               </a:defRPr>
             </a:pPr>
             <a:r>
-              <a:t>Planning prévu : France Travail à 7 h et 15 h ; JobsPipe à 7 h, heure de Paris. Reprises bornées et arrêt au quota. Le succès des nouveaux créneaux reste à observer.</a:t>
+              <a:t>Exports : France Travail à 7 h et 15 h ; JobsPipe à 7 h, heure de Paris. Reprises et pagination bornées. Les exécutions réussies doivent être montrées avec leur date.</a:t>
             </a:r>
           </a:p>
         </p:txBody>
@@ -11940,7 +11940,7 @@
               </a:defRPr>
             </a:pPr>
             <a:r>
-              <a:t>Projet étudiant · État documentaire au 19 septembre 2026 · Réserves et sources : DOSSIER_SOUTENANCE.md</a:t>
+              <a:t>Projet étudiant · État documentaire au 21 septembre 2026 · Réserves et sources : DOSSIER_SOUTENANCE.md</a:t>
             </a:r>
           </a:p>
         </p:txBody>
@@ -12636,7 +12636,7 @@
               </a:defRPr>
             </a:pPr>
             <a:r>
-              <a:t>Projet étudiant · État documentaire au 19 septembre 2026 · Réserves et sources : DOSSIER_SOUTENANCE.md</a:t>
+              <a:t>Projet étudiant · État documentaire au 21 septembre 2026 · Réserves et sources : DOSSIER_SOUTENANCE.md</a:t>
             </a:r>
           </a:p>
         </p:txBody>

</xml_diff>